<commit_message>
Tighten Files & Naming slice to its core slides
Drop the "Task Process Walkthrough" divider and the WIP figma slide from the
files-naming slice so it shows only File Storage, Naming conventions and
Folders.

Co-Authored-By: Claude Opus 4.8 <noreply@anthropic.com>
Claude-Session: https://claude.ai/code/session_01VKDuNmrVV4xGmEZbhZRuGo
</commit_message>
<xml_diff>
--- a/public/materials/slices/files-naming--playbook.pptx
+++ b/public/materials/slices/files-naming--playbook.pptx
@@ -8,8 +8,6 @@
     <p:notesMasterId r:id="rId32"/>
   </p:notesMasterIdLst>
   <p:sldIdLst>
-    <p:sldId id="263" r:id="rId17"/>
-    <p:sldId id="264" r:id="rId18"/>
     <p:sldId id="386" r:id="rId19"/>
     <p:sldId id="401" r:id="rId20"/>
     <p:sldId id="266" r:id="rId21"/>
@@ -10559,270 +10557,6 @@
 </p:sldMaster>
 </file>
 
-<file path=ppt/slides/slide13.xml><?xml version="1.0" encoding="utf-8"?>
-<p:sld xmlns:a="http://schemas.openxmlformats.org/drawingml/2006/main" xmlns:r="http://schemas.openxmlformats.org/officeDocument/2006/relationships" xmlns:p="http://schemas.openxmlformats.org/presentationml/2006/main">
-  <p:cSld>
-    <p:spTree>
-      <p:nvGrpSpPr>
-        <p:cNvPr id="1" name=""/>
-        <p:cNvGrpSpPr/>
-        <p:nvPr/>
-      </p:nvGrpSpPr>
-      <p:grpSpPr>
-        <a:xfrm>
-          <a:off x="0" y="0"/>
-          <a:ext cx="0" cy="0"/>
-          <a:chOff x="0" y="0"/>
-          <a:chExt cx="0" cy="0"/>
-        </a:xfrm>
-      </p:grpSpPr>
-      <p:sp>
-        <p:nvSpPr>
-          <p:cNvPr id="5" name="Marcador de texto 4">
-            <a:extLst>
-              <a:ext uri="{FF2B5EF4-FFF2-40B4-BE49-F238E27FC236}">
-                <a16:creationId xmlns:a16="http://schemas.microsoft.com/office/drawing/2014/main" id="{0F2DA7C0-3C95-AD34-F7DB-56F873C7BC2F}"/>
-              </a:ext>
-            </a:extLst>
-          </p:cNvPr>
-          <p:cNvSpPr>
-            <a:spLocks noGrp="1"/>
-          </p:cNvSpPr>
-          <p:nvPr>
-            <p:ph type="body" idx="1"/>
-          </p:nvPr>
-        </p:nvSpPr>
-        <p:spPr/>
-        <p:txBody>
-          <a:bodyPr/>
-          <a:lstStyle/>
-          <a:p>
-            <a:endParaRPr lang="es-ES"/>
-          </a:p>
-        </p:txBody>
-      </p:sp>
-      <p:sp>
-        <p:nvSpPr>
-          <p:cNvPr id="4" name="Título 3">
-            <a:extLst>
-              <a:ext uri="{FF2B5EF4-FFF2-40B4-BE49-F238E27FC236}">
-                <a16:creationId xmlns:a16="http://schemas.microsoft.com/office/drawing/2014/main" id="{1ACD8F7A-1210-087D-7DEE-73D74258A1C9}"/>
-              </a:ext>
-            </a:extLst>
-          </p:cNvPr>
-          <p:cNvSpPr>
-            <a:spLocks noGrp="1"/>
-          </p:cNvSpPr>
-          <p:nvPr>
-            <p:ph type="title"/>
-          </p:nvPr>
-        </p:nvSpPr>
-        <p:spPr/>
-        <p:txBody>
-          <a:bodyPr>
-            <a:normAutofit/>
-          </a:bodyPr>
-          <a:lstStyle/>
-          <a:p>
-            <a:r>
-              <a:rPr lang="en-US" dirty="0"/>
-              <a:t>Task Process Walkthrough</a:t>
-            </a:r>
-            <a:endParaRPr lang="es-ES" dirty="0"/>
-          </a:p>
-        </p:txBody>
-      </p:sp>
-      <p:sp>
-        <p:nvSpPr>
-          <p:cNvPr id="3" name="Marcador de número de diapositiva 2">
-            <a:extLst>
-              <a:ext uri="{FF2B5EF4-FFF2-40B4-BE49-F238E27FC236}">
-                <a16:creationId xmlns:a16="http://schemas.microsoft.com/office/drawing/2014/main" id="{F8C404E8-5258-A15E-8BEC-C70B0FC731C9}"/>
-              </a:ext>
-            </a:extLst>
-          </p:cNvPr>
-          <p:cNvSpPr>
-            <a:spLocks noGrp="1"/>
-          </p:cNvSpPr>
-          <p:nvPr>
-            <p:ph type="sldNum" sz="quarter" idx="12"/>
-          </p:nvPr>
-        </p:nvSpPr>
-        <p:spPr/>
-        <p:txBody>
-          <a:bodyPr/>
-          <a:lstStyle/>
-          <a:p>
-            <a:fld id="{66F6B9C1-1745-48B0-A8CA-B72E47831159}" type="slidenum">
-              <a:rPr lang="en-GB" noProof="0" smtClean="0"/>
-              <a:pPr/>
-              <a:t>13</a:t>
-            </a:fld>
-            <a:endParaRPr lang="en-GB" noProof="0"/>
-          </a:p>
-        </p:txBody>
-      </p:sp>
-    </p:spTree>
-    <p:extLst>
-      <p:ext uri="{BB962C8B-B14F-4D97-AF65-F5344CB8AC3E}">
-        <p14:creationId xmlns:p14="http://schemas.microsoft.com/office/powerpoint/2010/main" val="1097060231"/>
-      </p:ext>
-    </p:extLst>
-  </p:cSld>
-  <p:clrMapOvr>
-    <a:masterClrMapping/>
-  </p:clrMapOvr>
-</p:sld>
-</file>
-
-<file path=ppt/slides/slide14.xml><?xml version="1.0" encoding="utf-8"?>
-<p:sld xmlns:a="http://schemas.openxmlformats.org/drawingml/2006/main" xmlns:r="http://schemas.openxmlformats.org/officeDocument/2006/relationships" xmlns:p="http://schemas.openxmlformats.org/presentationml/2006/main">
-  <p:cSld>
-    <p:spTree>
-      <p:nvGrpSpPr>
-        <p:cNvPr id="1" name=""/>
-        <p:cNvGrpSpPr/>
-        <p:nvPr/>
-      </p:nvGrpSpPr>
-      <p:grpSpPr>
-        <a:xfrm>
-          <a:off x="0" y="0"/>
-          <a:ext cx="0" cy="0"/>
-          <a:chOff x="0" y="0"/>
-          <a:chExt cx="0" cy="0"/>
-        </a:xfrm>
-      </p:grpSpPr>
-      <p:sp>
-        <p:nvSpPr>
-          <p:cNvPr id="6" name="Marcador de contenido 5">
-            <a:extLst>
-              <a:ext uri="{FF2B5EF4-FFF2-40B4-BE49-F238E27FC236}">
-                <a16:creationId xmlns:a16="http://schemas.microsoft.com/office/drawing/2014/main" id="{47413B7D-14A2-14EE-F637-1BE2F4C7891C}"/>
-              </a:ext>
-            </a:extLst>
-          </p:cNvPr>
-          <p:cNvSpPr>
-            <a:spLocks noGrp="1"/>
-          </p:cNvSpPr>
-          <p:nvPr>
-            <p:ph idx="1"/>
-          </p:nvPr>
-        </p:nvSpPr>
-        <p:spPr/>
-        <p:txBody>
-          <a:bodyPr/>
-          <a:lstStyle/>
-          <a:p>
-            <a:r>
-              <a:rPr lang="es-ES" dirty="0"/>
-              <a:t>https://www.figma.com/board/KRZiC0me29aOCJBrfaRYPk/Untitled?node-id=3-579&amp;t=JFX3InyRx8QNRx1h-1</a:t>
-            </a:r>
-          </a:p>
-        </p:txBody>
-      </p:sp>
-      <p:sp>
-        <p:nvSpPr>
-          <p:cNvPr id="4" name="Marcador de número de diapositiva 3">
-            <a:extLst>
-              <a:ext uri="{FF2B5EF4-FFF2-40B4-BE49-F238E27FC236}">
-                <a16:creationId xmlns:a16="http://schemas.microsoft.com/office/drawing/2014/main" id="{2B408100-AA90-57DE-55FD-CA095BA2922E}"/>
-              </a:ext>
-            </a:extLst>
-          </p:cNvPr>
-          <p:cNvSpPr>
-            <a:spLocks noGrp="1"/>
-          </p:cNvSpPr>
-          <p:nvPr>
-            <p:ph type="sldNum" sz="quarter" idx="12"/>
-          </p:nvPr>
-        </p:nvSpPr>
-        <p:spPr/>
-        <p:txBody>
-          <a:bodyPr/>
-          <a:lstStyle/>
-          <a:p>
-            <a:fld id="{66F6B9C1-1745-48B0-A8CA-B72E47831159}" type="slidenum">
-              <a:rPr lang="en-GB" noProof="0" smtClean="0"/>
-              <a:pPr/>
-              <a:t>14</a:t>
-            </a:fld>
-            <a:endParaRPr lang="en-GB" noProof="0"/>
-          </a:p>
-        </p:txBody>
-      </p:sp>
-      <p:sp>
-        <p:nvSpPr>
-          <p:cNvPr id="5" name="Título 4">
-            <a:extLst>
-              <a:ext uri="{FF2B5EF4-FFF2-40B4-BE49-F238E27FC236}">
-                <a16:creationId xmlns:a16="http://schemas.microsoft.com/office/drawing/2014/main" id="{C4A4FCAB-D532-2CFC-3301-C06FEDCC87C1}"/>
-              </a:ext>
-            </a:extLst>
-          </p:cNvPr>
-          <p:cNvSpPr>
-            <a:spLocks noGrp="1"/>
-          </p:cNvSpPr>
-          <p:nvPr>
-            <p:ph type="title"/>
-          </p:nvPr>
-        </p:nvSpPr>
-        <p:spPr/>
-        <p:txBody>
-          <a:bodyPr/>
-          <a:lstStyle/>
-          <a:p>
-            <a:r>
-              <a:rPr lang="es-ES" dirty="0"/>
-              <a:t>First, </a:t>
-            </a:r>
-            <a:r>
-              <a:rPr lang="es-ES" dirty="0" err="1"/>
-              <a:t>where</a:t>
-            </a:r>
-            <a:r>
-              <a:rPr lang="es-ES" dirty="0"/>
-              <a:t> </a:t>
-            </a:r>
-            <a:r>
-              <a:rPr lang="es-ES" dirty="0" err="1"/>
-              <a:t>to</a:t>
-            </a:r>
-            <a:r>
-              <a:rPr lang="es-ES" dirty="0"/>
-              <a:t> </a:t>
-            </a:r>
-            <a:r>
-              <a:rPr lang="es-ES" dirty="0" err="1"/>
-              <a:t>find</a:t>
-            </a:r>
-            <a:r>
-              <a:rPr lang="es-ES" dirty="0"/>
-              <a:t> </a:t>
-            </a:r>
-            <a:r>
-              <a:rPr lang="es-ES" dirty="0" err="1"/>
-              <a:t>things</a:t>
-            </a:r>
-            <a:r>
-              <a:rPr lang="es-ES" dirty="0"/>
-              <a:t>? WIP</a:t>
-            </a:r>
-          </a:p>
-        </p:txBody>
-      </p:sp>
-    </p:spTree>
-    <p:extLst>
-      <p:ext uri="{BB962C8B-B14F-4D97-AF65-F5344CB8AC3E}">
-        <p14:creationId xmlns:p14="http://schemas.microsoft.com/office/powerpoint/2010/main" val="622944563"/>
-      </p:ext>
-    </p:extLst>
-  </p:cSld>
-  <p:clrMapOvr>
-    <a:masterClrMapping/>
-  </p:clrMapOvr>
-</p:sld>
-</file>
-
 <file path=ppt/slides/slide15.xml><?xml version="1.0" encoding="utf-8"?>
 <p:sld xmlns:a="http://schemas.openxmlformats.org/drawingml/2006/main" xmlns:r="http://schemas.openxmlformats.org/officeDocument/2006/relationships" xmlns:p="http://schemas.openxmlformats.org/presentationml/2006/main">
   <p:cSld>

</xml_diff>